<commit_message>
Append branch workflow guide to presentation
Co-authored-by: 36613453226Wallen <36613453226Wallen@users.noreply.github.com>
</commit_message>
<xml_diff>
--- a/Files/PPT-Producer/Teaching-Associate教授の助理 职位/GitHub三大核心概念.pptx
+++ b/Files/PPT-Producer/Teaching-Associate教授の助理 职位/GitHub三大核心概念.pptx
@@ -13,6 +13,7 @@
     <p:sldId id="258" r:id="rId6"/>
     <p:sldId id="259" r:id="rId7"/>
     <p:sldId id="260" r:id="rId8"/>
+    <p:sldId id="261" r:id="rId12"/>
   </p:sldIdLst>
   <p:sldSz cx="12191365" cy="6858000" type="screen4x3"/>
   <p:notesSz cx="6858000" cy="9144000"/>
@@ -11348,6 +11349,48 @@
           </a:p>
         </p:txBody>
       </p:sp>
+    </p:spTree>
+  </p:cSld>
+  <p:clrMapOvr>
+    <a:masterClrMapping/>
+  </p:clrMapOvr>
+</p:sld>
+</file>
+
+<file path=ppt/slides/slide6.xml><?xml version="1.0" encoding="utf-8"?>
+<p:sld xmlns:a="http://schemas.openxmlformats.org/drawingml/2006/main" xmlns:p="http://schemas.openxmlformats.org/presentationml/2006/main" xmlns:r="http://schemas.openxmlformats.org/officeDocument/2006/relationships">
+  <p:cSld>
+    <p:spTree>
+      <p:nvGrpSpPr>
+        <p:cNvPr id="1" name=""/>
+        <p:cNvGrpSpPr/>
+        <p:nvPr/>
+      </p:nvGrpSpPr>
+      <p:grpSpPr/>
+      <p:pic>
+        <p:nvPicPr>
+          <p:cNvPr id="2" name="Picture 1" descr="在未Merge条件下更新PPT文件.png"/>
+          <p:cNvPicPr>
+            <a:picLocks noChangeAspect="1"/>
+          </p:cNvPicPr>
+          <p:nvPr/>
+        </p:nvPicPr>
+        <p:blipFill>
+          <a:blip r:embed="rId2"/>
+          <a:stretch>
+            <a:fillRect/>
+          </a:stretch>
+        </p:blipFill>
+        <p:spPr>
+          <a:xfrm>
+            <a:off x="0" y="0"/>
+            <a:ext cx="12191365" cy="6858000"/>
+          </a:xfrm>
+          <a:prstGeom prst="rect">
+            <a:avLst/>
+          </a:prstGeom>
+        </p:spPr>
+      </p:pic>
     </p:spTree>
   </p:cSld>
   <p:clrMapOvr>

</xml_diff>

<commit_message>
Add Git usage questions presentation
Co-authored-by: 36613453226Wallen <36613453226Wallen@users.noreply.github.com>
</commit_message>
<xml_diff>
--- a/Files/PPT-Producer/Teaching-Associate教授の助理 职位/GitHub三大核心概念.pptx
+++ b/Files/PPT-Producer/Teaching-Associate教授の助理 职位/GitHub三大核心概念.pptx
@@ -14,6 +14,7 @@
     <p:sldId id="259" r:id="rId7"/>
     <p:sldId id="260" r:id="rId8"/>
     <p:sldId id="261" r:id="rId12"/>
+    <p:sldId id="262" r:id="rId13"/>
   </p:sldIdLst>
   <p:sldSz cx="12191365" cy="6858000" type="screen4x3"/>
   <p:notesSz cx="6858000" cy="9144000"/>
@@ -11391,6 +11392,505 @@
           </a:prstGeom>
         </p:spPr>
       </p:pic>
+    </p:spTree>
+  </p:cSld>
+  <p:clrMapOvr>
+    <a:masterClrMapping/>
+  </p:clrMapOvr>
+</p:sld>
+</file>
+
+<file path=ppt/slides/slide7.xml><?xml version="1.0" encoding="utf-8"?>
+<p:sld xmlns:a="http://schemas.openxmlformats.org/drawingml/2006/main" xmlns:p="http://schemas.openxmlformats.org/presentationml/2006/main" xmlns:r="http://schemas.openxmlformats.org/officeDocument/2006/relationships">
+  <p:cSld>
+    <p:bg>
+      <p:bgPr>
+        <a:solidFill>
+          <a:srgbClr val="F5F7FB"/>
+        </a:solidFill>
+        <a:effectLst/>
+      </p:bgPr>
+    </p:bg>
+    <p:spTree>
+      <p:nvGrpSpPr>
+        <p:cNvPr id="1" name=""/>
+        <p:cNvGrpSpPr/>
+        <p:nvPr/>
+      </p:nvGrpSpPr>
+      <p:grpSpPr/>
+      <p:sp>
+        <p:nvSpPr>
+          <p:cNvPr id="2" name="TextBox 1"/>
+          <p:cNvSpPr txBox="1"/>
+          <p:nvPr/>
+        </p:nvSpPr>
+        <p:spPr>
+          <a:xfrm>
+            <a:off x="658368" y="347472"/>
+            <a:ext cx="7040880" cy="475488"/>
+          </a:xfrm>
+          <a:prstGeom prst="rect">
+            <a:avLst/>
+          </a:prstGeom>
+          <a:noFill/>
+        </p:spPr>
+        <p:txBody>
+          <a:bodyPr wrap="square" anchor="ctr" lIns="54864" rIns="54864" tIns="54864" bIns="54864">
+            <a:spAutoFit/>
+          </a:bodyPr>
+          <a:lstStyle/>
+          <a:p>
+            <a:pPr algn="l">
+              <a:spcAft>
+                <a:spcPts val="0"/>
+              </a:spcAft>
+            </a:pPr>
+            <a:r>
+              <a:rPr sz="2600" b="1">
+                <a:solidFill>
+                  <a:srgbClr val="24324A"/>
+                </a:solidFill>
+                <a:latin typeface="Microsoft YaHei"/>
+              </a:rPr>
+              <a:t>“166 commits ahead”是什么意思？</a:t>
+            </a:r>
+          </a:p>
+        </p:txBody>
+      </p:sp>
+      <p:pic>
+        <p:nvPicPr>
+          <p:cNvPr id="3" name="Picture 2" descr="166-commits-ahead.png"/>
+          <p:cNvPicPr>
+            <a:picLocks noChangeAspect="1"/>
+          </p:cNvPicPr>
+          <p:nvPr/>
+        </p:nvPicPr>
+        <p:blipFill>
+          <a:blip r:embed="rId2"/>
+          <a:stretch>
+            <a:fillRect/>
+          </a:stretch>
+        </p:blipFill>
+        <p:spPr>
+          <a:xfrm>
+            <a:off x="676656" y="1078992"/>
+            <a:ext cx="10835640" cy="1240224"/>
+          </a:xfrm>
+          <a:prstGeom prst="rect">
+            <a:avLst/>
+          </a:prstGeom>
+        </p:spPr>
+      </p:pic>
+      <p:sp>
+        <p:nvSpPr>
+          <p:cNvPr id="4" name="Rounded Rectangle 3"/>
+          <p:cNvSpPr/>
+          <p:nvPr/>
+        </p:nvSpPr>
+        <p:spPr>
+          <a:xfrm>
+            <a:off x="676656" y="2057400"/>
+            <a:ext cx="5212080" cy="3383280"/>
+          </a:xfrm>
+          <a:prstGeom prst="roundRect">
+            <a:avLst/>
+          </a:prstGeom>
+          <a:solidFill>
+            <a:srgbClr val="FFFFFF"/>
+          </a:solidFill>
+          <a:ln w="12700">
+            <a:solidFill>
+              <a:srgbClr val="DCE3ED"/>
+            </a:solidFill>
+          </a:ln>
+        </p:spPr>
+        <p:style>
+          <a:lnRef idx="1">
+            <a:schemeClr val="accent1"/>
+          </a:lnRef>
+          <a:fillRef idx="3">
+            <a:schemeClr val="accent1"/>
+          </a:fillRef>
+          <a:effectRef idx="2">
+            <a:schemeClr val="accent1"/>
+          </a:effectRef>
+          <a:fontRef idx="minor">
+            <a:schemeClr val="lt1"/>
+          </a:fontRef>
+        </p:style>
+        <p:txBody>
+          <a:bodyPr rtlCol="0" anchor="ctr"/>
+          <a:lstStyle/>
+          <a:p>
+            <a:pPr algn="ctr"/>
+          </a:p>
+        </p:txBody>
+      </p:sp>
+      <p:sp>
+        <p:nvSpPr>
+          <p:cNvPr id="5" name="TextBox 4"/>
+          <p:cNvSpPr txBox="1"/>
+          <p:nvPr/>
+        </p:nvSpPr>
+        <p:spPr>
+          <a:xfrm>
+            <a:off x="932688" y="2313432"/>
+            <a:ext cx="1325880" cy="347472"/>
+          </a:xfrm>
+          <a:prstGeom prst="rect">
+            <a:avLst/>
+          </a:prstGeom>
+          <a:noFill/>
+        </p:spPr>
+        <p:txBody>
+          <a:bodyPr wrap="square" anchor="ctr" lIns="54864" rIns="54864" tIns="54864" bIns="54864">
+            <a:spAutoFit/>
+          </a:bodyPr>
+          <a:lstStyle/>
+          <a:p>
+            <a:pPr algn="l">
+              <a:spcAft>
+                <a:spcPts val="0"/>
+              </a:spcAft>
+            </a:pPr>
+            <a:r>
+              <a:rPr sz="1500" b="1">
+                <a:solidFill>
+                  <a:srgbClr val="2F6BFF"/>
+                </a:solidFill>
+                <a:latin typeface="Microsoft YaHei"/>
+              </a:rPr>
+              <a:t>简短回答</a:t>
+            </a:r>
+          </a:p>
+        </p:txBody>
+      </p:sp>
+      <p:sp>
+        <p:nvSpPr>
+          <p:cNvPr id="6" name="TextBox 5"/>
+          <p:cNvSpPr txBox="1"/>
+          <p:nvPr/>
+        </p:nvSpPr>
+        <p:spPr>
+          <a:xfrm>
+            <a:off x="932688" y="2852928"/>
+            <a:ext cx="4709160" cy="2057400"/>
+          </a:xfrm>
+          <a:prstGeom prst="rect">
+            <a:avLst/>
+          </a:prstGeom>
+          <a:noFill/>
+        </p:spPr>
+        <p:txBody>
+          <a:bodyPr wrap="square" anchor="t" lIns="54864" rIns="54864" tIns="54864" bIns="54864">
+            <a:spAutoFit/>
+          </a:bodyPr>
+          <a:lstStyle/>
+          <a:p>
+            <a:pPr algn="l">
+              <a:spcAft>
+                <a:spcPts val="0"/>
+              </a:spcAft>
+            </a:pPr>
+            <a:r>
+              <a:rPr sz="1800" b="0">
+                <a:solidFill>
+                  <a:srgbClr val="24324A"/>
+                </a:solidFill>
+                <a:latin typeface="Microsoft YaHei"/>
+              </a:rPr>
+              <a:t>当前分支中有 166 个提交尚未包含在目标仓库的 master 分支中。这不是报错，也不是 166 个文件；合并前应确认这些提交都是预期内容。</a:t>
+            </a:r>
+          </a:p>
+        </p:txBody>
+      </p:sp>
+      <p:sp>
+        <p:nvSpPr>
+          <p:cNvPr id="7" name="Rounded Rectangle 6"/>
+          <p:cNvSpPr/>
+          <p:nvPr/>
+        </p:nvSpPr>
+        <p:spPr>
+          <a:xfrm>
+            <a:off x="6217920" y="2057400"/>
+            <a:ext cx="5285232" cy="1499616"/>
+          </a:xfrm>
+          <a:prstGeom prst="roundRect">
+            <a:avLst/>
+          </a:prstGeom>
+          <a:solidFill>
+            <a:srgbClr val="EAF0FF"/>
+          </a:solidFill>
+          <a:ln w="12700">
+            <a:solidFill>
+              <a:srgbClr val="EAF0FF"/>
+            </a:solidFill>
+          </a:ln>
+        </p:spPr>
+        <p:style>
+          <a:lnRef idx="1">
+            <a:schemeClr val="accent1"/>
+          </a:lnRef>
+          <a:fillRef idx="3">
+            <a:schemeClr val="accent1"/>
+          </a:fillRef>
+          <a:effectRef idx="2">
+            <a:schemeClr val="accent1"/>
+          </a:effectRef>
+          <a:fontRef idx="minor">
+            <a:schemeClr val="lt1"/>
+          </a:fontRef>
+        </p:style>
+        <p:txBody>
+          <a:bodyPr rtlCol="0" anchor="ctr"/>
+          <a:lstStyle/>
+          <a:p>
+            <a:pPr algn="ctr"/>
+          </a:p>
+        </p:txBody>
+      </p:sp>
+      <p:sp>
+        <p:nvSpPr>
+          <p:cNvPr id="8" name="TextBox 7"/>
+          <p:cNvSpPr txBox="1"/>
+          <p:nvPr/>
+        </p:nvSpPr>
+        <p:spPr>
+          <a:xfrm>
+            <a:off x="6455664" y="2258568"/>
+            <a:ext cx="1280160" cy="292608"/>
+          </a:xfrm>
+          <a:prstGeom prst="rect">
+            <a:avLst/>
+          </a:prstGeom>
+          <a:noFill/>
+        </p:spPr>
+        <p:txBody>
+          <a:bodyPr wrap="square" anchor="ctr" lIns="54864" rIns="54864" tIns="54864" bIns="54864">
+            <a:spAutoFit/>
+          </a:bodyPr>
+          <a:lstStyle/>
+          <a:p>
+            <a:pPr algn="l">
+              <a:spcAft>
+                <a:spcPts val="0"/>
+              </a:spcAft>
+            </a:pPr>
+            <a:r>
+              <a:rPr sz="1500" b="1">
+                <a:solidFill>
+                  <a:srgbClr val="2F6BFF"/>
+                </a:solidFill>
+                <a:latin typeface="Microsoft YaHei"/>
+              </a:rPr>
+              <a:t>英文 OCR</a:t>
+            </a:r>
+          </a:p>
+        </p:txBody>
+      </p:sp>
+      <p:sp>
+        <p:nvSpPr>
+          <p:cNvPr id="9" name="TextBox 8"/>
+          <p:cNvSpPr txBox="1"/>
+          <p:nvPr/>
+        </p:nvSpPr>
+        <p:spPr>
+          <a:xfrm>
+            <a:off x="6455664" y="2651760"/>
+            <a:ext cx="4663440" cy="640080"/>
+          </a:xfrm>
+          <a:prstGeom prst="rect">
+            <a:avLst/>
+          </a:prstGeom>
+          <a:noFill/>
+        </p:spPr>
+        <p:txBody>
+          <a:bodyPr wrap="square" anchor="t" lIns="54864" rIns="54864" tIns="54864" bIns="54864">
+            <a:spAutoFit/>
+          </a:bodyPr>
+          <a:lstStyle/>
+          <a:p>
+            <a:pPr algn="l">
+              <a:spcAft>
+                <a:spcPts val="0"/>
+              </a:spcAft>
+            </a:pPr>
+            <a:r>
+              <a:rPr sz="1500" b="0">
+                <a:solidFill>
+                  <a:srgbClr val="24324A"/>
+                </a:solidFill>
+                <a:latin typeface="Aptos"/>
+              </a:rPr>
+              <a:t>This branch is 166 commits ahead of
+LeonYanghaha/pua-books:master.</a:t>
+            </a:r>
+          </a:p>
+        </p:txBody>
+      </p:sp>
+      <p:sp>
+        <p:nvSpPr>
+          <p:cNvPr id="10" name="Rounded Rectangle 9"/>
+          <p:cNvSpPr/>
+          <p:nvPr/>
+        </p:nvSpPr>
+        <p:spPr>
+          <a:xfrm>
+            <a:off x="6217920" y="3931920"/>
+            <a:ext cx="5285232" cy="1499616"/>
+          </a:xfrm>
+          <a:prstGeom prst="roundRect">
+            <a:avLst/>
+          </a:prstGeom>
+          <a:solidFill>
+            <a:srgbClr val="E5F6EF"/>
+          </a:solidFill>
+          <a:ln w="12700">
+            <a:solidFill>
+              <a:srgbClr val="E5F6EF"/>
+            </a:solidFill>
+          </a:ln>
+        </p:spPr>
+        <p:style>
+          <a:lnRef idx="1">
+            <a:schemeClr val="accent1"/>
+          </a:lnRef>
+          <a:fillRef idx="3">
+            <a:schemeClr val="accent1"/>
+          </a:fillRef>
+          <a:effectRef idx="2">
+            <a:schemeClr val="accent1"/>
+          </a:effectRef>
+          <a:fontRef idx="minor">
+            <a:schemeClr val="lt1"/>
+          </a:fontRef>
+        </p:style>
+        <p:txBody>
+          <a:bodyPr rtlCol="0" anchor="ctr"/>
+          <a:lstStyle/>
+          <a:p>
+            <a:pPr algn="ctr"/>
+          </a:p>
+        </p:txBody>
+      </p:sp>
+      <p:sp>
+        <p:nvSpPr>
+          <p:cNvPr id="11" name="TextBox 10"/>
+          <p:cNvSpPr txBox="1"/>
+          <p:nvPr/>
+        </p:nvSpPr>
+        <p:spPr>
+          <a:xfrm>
+            <a:off x="6455664" y="4133087"/>
+            <a:ext cx="1280160" cy="292608"/>
+          </a:xfrm>
+          <a:prstGeom prst="rect">
+            <a:avLst/>
+          </a:prstGeom>
+          <a:noFill/>
+        </p:spPr>
+        <p:txBody>
+          <a:bodyPr wrap="square" anchor="ctr" lIns="54864" rIns="54864" tIns="54864" bIns="54864">
+            <a:spAutoFit/>
+          </a:bodyPr>
+          <a:lstStyle/>
+          <a:p>
+            <a:pPr algn="l">
+              <a:spcAft>
+                <a:spcPts val="0"/>
+              </a:spcAft>
+            </a:pPr>
+            <a:r>
+              <a:rPr sz="1500" b="1">
+                <a:solidFill>
+                  <a:srgbClr val="15966A"/>
+                </a:solidFill>
+                <a:latin typeface="Microsoft YaHei"/>
+              </a:rPr>
+              <a:t>中文翻译</a:t>
+            </a:r>
+          </a:p>
+        </p:txBody>
+      </p:sp>
+      <p:sp>
+        <p:nvSpPr>
+          <p:cNvPr id="12" name="TextBox 11"/>
+          <p:cNvSpPr txBox="1"/>
+          <p:nvPr/>
+        </p:nvSpPr>
+        <p:spPr>
+          <a:xfrm>
+            <a:off x="6455664" y="4526280"/>
+            <a:ext cx="4663440" cy="640080"/>
+          </a:xfrm>
+          <a:prstGeom prst="rect">
+            <a:avLst/>
+          </a:prstGeom>
+          <a:noFill/>
+        </p:spPr>
+        <p:txBody>
+          <a:bodyPr wrap="square" anchor="t" lIns="54864" rIns="54864" tIns="54864" bIns="54864">
+            <a:spAutoFit/>
+          </a:bodyPr>
+          <a:lstStyle/>
+          <a:p>
+            <a:pPr algn="l">
+              <a:spcAft>
+                <a:spcPts val="0"/>
+              </a:spcAft>
+            </a:pPr>
+            <a:r>
+              <a:rPr sz="1500" b="0">
+                <a:solidFill>
+                  <a:srgbClr val="24324A"/>
+                </a:solidFill>
+                <a:latin typeface="Microsoft YaHei"/>
+              </a:rPr>
+              <a:t>此分支比 LeonYanghaha/pua-books 的
+master 分支领先 166 个提交。</a:t>
+            </a:r>
+          </a:p>
+        </p:txBody>
+      </p:sp>
+      <p:sp>
+        <p:nvSpPr>
+          <p:cNvPr id="13" name="TextBox 12"/>
+          <p:cNvSpPr txBox="1"/>
+          <p:nvPr/>
+        </p:nvSpPr>
+        <p:spPr>
+          <a:xfrm>
+            <a:off x="713232" y="5998464"/>
+            <a:ext cx="7772400" cy="274320"/>
+          </a:xfrm>
+          <a:prstGeom prst="rect">
+            <a:avLst/>
+          </a:prstGeom>
+          <a:noFill/>
+        </p:spPr>
+        <p:txBody>
+          <a:bodyPr wrap="square" anchor="ctr" lIns="54864" rIns="54864" tIns="54864" bIns="54864">
+            <a:spAutoFit/>
+          </a:bodyPr>
+          <a:lstStyle/>
+          <a:p>
+            <a:pPr algn="l">
+              <a:spcAft>
+                <a:spcPts val="0"/>
+              </a:spcAft>
+            </a:pPr>
+            <a:r>
+              <a:rPr sz="1100" b="0">
+                <a:solidFill>
+                  <a:srgbClr val="6B778C"/>
+                </a:solidFill>
+                <a:latin typeface="Microsoft YaHei"/>
+              </a:rPr>
+              <a:t>注：ahead 只比较提交历史是否已被目标分支包含。</a:t>
+            </a:r>
+          </a:p>
+        </p:txBody>
+      </p:sp>
     </p:spTree>
   </p:cSld>
   <p:clrMapOvr>

</xml_diff>